<commit_message>
feat: perbarui pengalaman Cerebrum jadi Data Analyst → Data & AI Engineer
- Experience: pisah Cerebrum menjadi Data Analyst (Nov 2025 – May 2026)
  dan Data & AI Engineer (May 2026 – sekarang), poin dari proyek kerja
  (forecasting, QC Agent, generator soal, pipeline LLM, ProductTrack + MCP,
  analisis tiket Report Center); terjemahan ID ikut diperbarui
- About: label peran dan paragraf diperbarui; tambah "AI Engineer" di
  teks peran hero dan metadata JSON-LD
- Resume PDF diregenerasi dari generate_resume.py
- Deck PPTX + PDF (utama & minimal): timeline slide 4 jadi 5 kolom,
  peran di slide 1/11 diperbarui
</commit_message>
<xml_diff>
--- a/outputs/Muhammad_Ali_Akbar_Al-Qahri_Portfolio.pptx
+++ b/outputs/Muhammad_Ali_Akbar_Al-Qahri_Portfolio.pptx
@@ -2390,7 +2390,7 @@
               </a:defRPr>
             </a:pPr>
             <a:r>
-              <a:t>DATA ANALYST  /  DATA SCIENTIST  /  DATABASE ENGINEER</a:t>
+              <a:t>DATA &amp; AI ENGINEER  /  DATA ANALYST  /  DATA SCIENTIST</a:t>
             </a:r>
           </a:p>
         </p:txBody>
@@ -4401,7 +4401,7 @@
               </a:defRPr>
             </a:pPr>
             <a:r>
-              <a:t>Available for data analyst, business intelligence, data science, and data engineering opportunities.</a:t>
+              <a:t>Available for data &amp; AI engineering, analytics, BI, and data science opportunities.</a:t>
             </a:r>
           </a:p>
         </p:txBody>
@@ -7306,7 +7306,7 @@
         <p:spPr>
           <a:xfrm xmlns:a="http://schemas.openxmlformats.org/drawingml/2006/main">
             <a:off x="400050" y="2238375"/>
-            <a:ext cx="2476500" cy="285750"/>
+            <a:ext cx="2130552" cy="285750"/>
           </a:xfrm>
           <a:prstGeom xmlns:a="http://schemas.openxmlformats.org/drawingml/2006/main" prst="rect">
             <a:avLst/>
@@ -7351,7 +7351,7 @@
         <p:spPr>
           <a:xfrm xmlns:a="http://schemas.openxmlformats.org/drawingml/2006/main">
             <a:off x="400050" y="3343275"/>
-            <a:ext cx="2400300" cy="552450"/>
+            <a:ext cx="2130552" cy="552450"/>
           </a:xfrm>
           <a:prstGeom xmlns:a="http://schemas.openxmlformats.org/drawingml/2006/main" prst="rect">
             <a:avLst/>
@@ -7396,7 +7396,7 @@
         <p:spPr>
           <a:xfrm xmlns:a="http://schemas.openxmlformats.org/drawingml/2006/main">
             <a:off x="400050" y="3971925"/>
-            <a:ext cx="2381250" cy="466725"/>
+            <a:ext cx="2130552" cy="466725"/>
           </a:xfrm>
           <a:prstGeom xmlns:a="http://schemas.openxmlformats.org/drawingml/2006/main" prst="rect">
             <a:avLst/>
@@ -7441,7 +7441,7 @@
         <p:spPr>
           <a:xfrm xmlns:a="http://schemas.openxmlformats.org/drawingml/2006/main">
             <a:off x="400050" y="4695825"/>
-            <a:ext cx="2400300" cy="552450"/>
+            <a:ext cx="2130552" cy="822960"/>
           </a:xfrm>
           <a:prstGeom xmlns:a="http://schemas.openxmlformats.org/drawingml/2006/main" prst="rect">
             <a:avLst/>
@@ -7485,7 +7485,7 @@
         </p:nvSpPr>
         <p:spPr>
           <a:xfrm xmlns:a="http://schemas.openxmlformats.org/drawingml/2006/main">
-            <a:off x="3400425" y="2714625"/>
+            <a:off x="2856357" y="2714625"/>
             <a:ext cx="361950" cy="361950"/>
           </a:xfrm>
           <a:prstGeom xmlns:a="http://schemas.openxmlformats.org/drawingml/2006/main" prst="roundRect">
@@ -7514,7 +7514,7 @@
         </p:nvSpPr>
         <p:spPr>
           <a:xfrm xmlns:a="http://schemas.openxmlformats.org/drawingml/2006/main">
-            <a:off x="3524250" y="2838450"/>
+            <a:off x="2980182" y="2838450"/>
             <a:ext cx="114300" cy="114300"/>
           </a:xfrm>
           <a:prstGeom xmlns:a="http://schemas.openxmlformats.org/drawingml/2006/main" prst="roundRect">
@@ -7543,8 +7543,8 @@
         </p:nvSpPr>
         <p:spPr>
           <a:xfrm xmlns:a="http://schemas.openxmlformats.org/drawingml/2006/main">
-            <a:off x="3257550" y="2238375"/>
-            <a:ext cx="2476500" cy="285750"/>
+            <a:off x="2713482" y="2238375"/>
+            <a:ext cx="2130552" cy="285750"/>
           </a:xfrm>
           <a:prstGeom xmlns:a="http://schemas.openxmlformats.org/drawingml/2006/main" prst="rect">
             <a:avLst/>
@@ -7588,8 +7588,8 @@
         </p:nvSpPr>
         <p:spPr>
           <a:xfrm xmlns:a="http://schemas.openxmlformats.org/drawingml/2006/main">
-            <a:off x="3257550" y="3343275"/>
-            <a:ext cx="2400300" cy="552450"/>
+            <a:off x="2713482" y="3343275"/>
+            <a:ext cx="2130552" cy="552450"/>
           </a:xfrm>
           <a:prstGeom xmlns:a="http://schemas.openxmlformats.org/drawingml/2006/main" prst="rect">
             <a:avLst/>
@@ -7633,8 +7633,8 @@
         </p:nvSpPr>
         <p:spPr>
           <a:xfrm xmlns:a="http://schemas.openxmlformats.org/drawingml/2006/main">
-            <a:off x="3257550" y="3971925"/>
-            <a:ext cx="2381250" cy="466725"/>
+            <a:off x="2713482" y="3971925"/>
+            <a:ext cx="2130552" cy="466725"/>
           </a:xfrm>
           <a:prstGeom xmlns:a="http://schemas.openxmlformats.org/drawingml/2006/main" prst="rect">
             <a:avLst/>
@@ -7678,8 +7678,8 @@
         </p:nvSpPr>
         <p:spPr>
           <a:xfrm xmlns:a="http://schemas.openxmlformats.org/drawingml/2006/main">
-            <a:off x="3257550" y="4695825"/>
-            <a:ext cx="2400300" cy="552450"/>
+            <a:off x="2713482" y="4695825"/>
+            <a:ext cx="2130552" cy="822960"/>
           </a:xfrm>
           <a:prstGeom xmlns:a="http://schemas.openxmlformats.org/drawingml/2006/main" prst="rect">
             <a:avLst/>
@@ -7723,7 +7723,7 @@
         </p:nvSpPr>
         <p:spPr>
           <a:xfrm xmlns:a="http://schemas.openxmlformats.org/drawingml/2006/main">
-            <a:off x="6257925" y="2714625"/>
+            <a:off x="5169789" y="2714625"/>
             <a:ext cx="361950" cy="361950"/>
           </a:xfrm>
           <a:prstGeom xmlns:a="http://schemas.openxmlformats.org/drawingml/2006/main" prst="roundRect">
@@ -7752,7 +7752,7 @@
         </p:nvSpPr>
         <p:spPr>
           <a:xfrm xmlns:a="http://schemas.openxmlformats.org/drawingml/2006/main">
-            <a:off x="6381750" y="2838450"/>
+            <a:off x="5293614" y="2838450"/>
             <a:ext cx="114300" cy="114300"/>
           </a:xfrm>
           <a:prstGeom xmlns:a="http://schemas.openxmlformats.org/drawingml/2006/main" prst="roundRect">
@@ -7781,8 +7781,8 @@
         </p:nvSpPr>
         <p:spPr>
           <a:xfrm xmlns:a="http://schemas.openxmlformats.org/drawingml/2006/main">
-            <a:off x="6115050" y="2238375"/>
-            <a:ext cx="2476500" cy="285750"/>
+            <a:off x="5026914" y="2238375"/>
+            <a:ext cx="2130552" cy="285750"/>
           </a:xfrm>
           <a:prstGeom xmlns:a="http://schemas.openxmlformats.org/drawingml/2006/main" prst="rect">
             <a:avLst/>
@@ -7826,8 +7826,8 @@
         </p:nvSpPr>
         <p:spPr>
           <a:xfrm xmlns:a="http://schemas.openxmlformats.org/drawingml/2006/main">
-            <a:off x="6115050" y="3343275"/>
-            <a:ext cx="2400300" cy="552450"/>
+            <a:off x="5026914" y="3343275"/>
+            <a:ext cx="2130552" cy="552450"/>
           </a:xfrm>
           <a:prstGeom xmlns:a="http://schemas.openxmlformats.org/drawingml/2006/main" prst="rect">
             <a:avLst/>
@@ -7871,8 +7871,8 @@
         </p:nvSpPr>
         <p:spPr>
           <a:xfrm xmlns:a="http://schemas.openxmlformats.org/drawingml/2006/main">
-            <a:off x="6115050" y="3971925"/>
-            <a:ext cx="2381250" cy="466725"/>
+            <a:off x="5026914" y="3971925"/>
+            <a:ext cx="2130552" cy="466725"/>
           </a:xfrm>
           <a:prstGeom xmlns:a="http://schemas.openxmlformats.org/drawingml/2006/main" prst="rect">
             <a:avLst/>
@@ -7916,8 +7916,8 @@
         </p:nvSpPr>
         <p:spPr>
           <a:xfrm xmlns:a="http://schemas.openxmlformats.org/drawingml/2006/main">
-            <a:off x="6115050" y="4695825"/>
-            <a:ext cx="2400300" cy="552450"/>
+            <a:off x="5026914" y="4695825"/>
+            <a:ext cx="2130552" cy="822960"/>
           </a:xfrm>
           <a:prstGeom xmlns:a="http://schemas.openxmlformats.org/drawingml/2006/main" prst="rect">
             <a:avLst/>
@@ -7961,7 +7961,7 @@
         </p:nvSpPr>
         <p:spPr>
           <a:xfrm xmlns:a="http://schemas.openxmlformats.org/drawingml/2006/main">
-            <a:off x="9115425" y="2714625"/>
+            <a:off x="7483221" y="2714625"/>
             <a:ext cx="361950" cy="361950"/>
           </a:xfrm>
           <a:prstGeom xmlns:a="http://schemas.openxmlformats.org/drawingml/2006/main" prst="roundRect">
@@ -7970,7 +7970,7 @@
             </a:avLst>
           </a:prstGeom>
           <a:solidFill xmlns:a="http://schemas.openxmlformats.org/drawingml/2006/main">
-            <a:srgbClr val="F6C453"/>
+            <a:srgbClr val="2A1A17"/>
           </a:solidFill>
         </p:spPr>
       </p:sp>
@@ -7990,7 +7990,7 @@
         </p:nvSpPr>
         <p:spPr>
           <a:xfrm xmlns:a="http://schemas.openxmlformats.org/drawingml/2006/main">
-            <a:off x="9239250" y="2838450"/>
+            <a:off x="7607046" y="2838450"/>
             <a:ext cx="114300" cy="114300"/>
           </a:xfrm>
           <a:prstGeom xmlns:a="http://schemas.openxmlformats.org/drawingml/2006/main" prst="roundRect">
@@ -7999,7 +7999,7 @@
             </a:avLst>
           </a:prstGeom>
           <a:solidFill xmlns:a="http://schemas.openxmlformats.org/drawingml/2006/main">
-            <a:srgbClr val="FFF7ED"/>
+            <a:srgbClr val="F6C453"/>
           </a:solidFill>
         </p:spPr>
       </p:sp>
@@ -8019,8 +8019,8 @@
         </p:nvSpPr>
         <p:spPr>
           <a:xfrm xmlns:a="http://schemas.openxmlformats.org/drawingml/2006/main">
-            <a:off x="8972550" y="2238375"/>
-            <a:ext cx="2476500" cy="285750"/>
+            <a:off x="7340346" y="2238375"/>
+            <a:ext cx="2130552" cy="285750"/>
           </a:xfrm>
           <a:prstGeom xmlns:a="http://schemas.openxmlformats.org/drawingml/2006/main" prst="rect">
             <a:avLst/>
@@ -8043,7 +8043,7 @@
               </a:defRPr>
             </a:pPr>
             <a:r>
-              <a:t>2025–now</a:t>
+              <a:t>2025–26</a:t>
             </a:r>
           </a:p>
         </p:txBody>
@@ -8064,8 +8064,8 @@
         </p:nvSpPr>
         <p:spPr>
           <a:xfrm xmlns:a="http://schemas.openxmlformats.org/drawingml/2006/main">
-            <a:off x="8972550" y="3343275"/>
-            <a:ext cx="2400300" cy="552450"/>
+            <a:off x="7340346" y="3343275"/>
+            <a:ext cx="2130552" cy="552450"/>
           </a:xfrm>
           <a:prstGeom xmlns:a="http://schemas.openxmlformats.org/drawingml/2006/main" prst="rect">
             <a:avLst/>
@@ -8109,8 +8109,8 @@
         </p:nvSpPr>
         <p:spPr>
           <a:xfrm xmlns:a="http://schemas.openxmlformats.org/drawingml/2006/main">
-            <a:off x="8972550" y="3971925"/>
-            <a:ext cx="2381250" cy="466725"/>
+            <a:off x="7340346" y="3971925"/>
+            <a:ext cx="2130552" cy="466725"/>
           </a:xfrm>
           <a:prstGeom xmlns:a="http://schemas.openxmlformats.org/drawingml/2006/main" prst="rect">
             <a:avLst/>
@@ -8154,8 +8154,8 @@
         </p:nvSpPr>
         <p:spPr>
           <a:xfrm xmlns:a="http://schemas.openxmlformats.org/drawingml/2006/main">
-            <a:off x="8972550" y="4695825"/>
-            <a:ext cx="2400300" cy="552450"/>
+            <a:off x="7340346" y="4695825"/>
+            <a:ext cx="2130552" cy="822960"/>
           </a:xfrm>
           <a:prstGeom xmlns:a="http://schemas.openxmlformats.org/drawingml/2006/main" prst="rect">
             <a:avLst/>
@@ -8178,7 +8178,245 @@
               </a:defRPr>
             </a:pPr>
             <a:r>
-              <a:t>MySQL ETL · Power BI KPI systems</a:t>
+              <a:t>Prophet forecasting · Power BI KPI dashboards</a:t>
+            </a:r>
+          </a:p>
+        </p:txBody>
+      </p:sp>
+      <p:sp>
+        <p:nvSpPr>
+          <p:cNvPr id="38" name="timeline-dot-4">
+            <a:extLst xmlns:a="http://schemas.openxmlformats.org/drawingml/2006/main">
+              <a:ext uri="{FF2B5EF4-FFF2-40B4-BE49-F238E27FC236}">
+                <a16:creationId xmlns:a16="http://schemas.microsoft.com/office/drawing/2014/main" id="{32ED1BD9-C8F1-49A6-8FEF-931E60DE534E}"/>
+              </a:ext>
+            </a:extLst>
+          </p:cNvPr>
+          <p:cNvSpPr>
+            <a:spLocks xmlns:a="http://schemas.openxmlformats.org/drawingml/2006/main" noGrp="1"/>
+          </p:cNvSpPr>
+          <p:nvPr/>
+        </p:nvSpPr>
+        <p:spPr>
+          <a:xfrm xmlns:a="http://schemas.openxmlformats.org/drawingml/2006/main">
+            <a:off x="9796653" y="2714625"/>
+            <a:ext cx="361950" cy="361950"/>
+          </a:xfrm>
+          <a:prstGeom xmlns:a="http://schemas.openxmlformats.org/drawingml/2006/main" prst="roundRect">
+            <a:avLst>
+              <a:gd name="adj" fmla="val 21053"/>
+            </a:avLst>
+          </a:prstGeom>
+          <a:solidFill xmlns:a="http://schemas.openxmlformats.org/drawingml/2006/main">
+            <a:srgbClr val="F6C453"/>
+          </a:solidFill>
+        </p:spPr>
+      </p:sp>
+      <p:sp>
+        <p:nvSpPr>
+          <p:cNvPr id="39" name="timeline-dot-core-4">
+            <a:extLst xmlns:a="http://schemas.openxmlformats.org/drawingml/2006/main">
+              <a:ext uri="{FF2B5EF4-FFF2-40B4-BE49-F238E27FC236}">
+                <a16:creationId xmlns:a16="http://schemas.microsoft.com/office/drawing/2014/main" id="{694D59E8-8477-46CC-AE62-E128D2C1AB3D}"/>
+              </a:ext>
+            </a:extLst>
+          </p:cNvPr>
+          <p:cNvSpPr>
+            <a:spLocks xmlns:a="http://schemas.openxmlformats.org/drawingml/2006/main" noGrp="1"/>
+          </p:cNvSpPr>
+          <p:nvPr/>
+        </p:nvSpPr>
+        <p:spPr>
+          <a:xfrm xmlns:a="http://schemas.openxmlformats.org/drawingml/2006/main">
+            <a:off x="9920478" y="2838450"/>
+            <a:ext cx="114300" cy="114300"/>
+          </a:xfrm>
+          <a:prstGeom xmlns:a="http://schemas.openxmlformats.org/drawingml/2006/main" prst="roundRect">
+            <a:avLst>
+              <a:gd name="adj" fmla="val 50000"/>
+            </a:avLst>
+          </a:prstGeom>
+          <a:solidFill xmlns:a="http://schemas.openxmlformats.org/drawingml/2006/main">
+            <a:srgbClr val="FFF7ED"/>
+          </a:solidFill>
+        </p:spPr>
+      </p:sp>
+      <p:sp>
+        <p:nvSpPr>
+          <p:cNvPr id="40" name="timeline-period-4">
+            <a:extLst xmlns:a="http://schemas.openxmlformats.org/drawingml/2006/main">
+              <a:ext uri="{FF2B5EF4-FFF2-40B4-BE49-F238E27FC236}">
+                <a16:creationId xmlns:a16="http://schemas.microsoft.com/office/drawing/2014/main" id="{E0C322C1-7B1D-4553-941D-A8DE3E4AE77A}"/>
+              </a:ext>
+            </a:extLst>
+          </p:cNvPr>
+          <p:cNvSpPr>
+            <a:spLocks xmlns:a="http://schemas.openxmlformats.org/drawingml/2006/main" noGrp="1"/>
+          </p:cNvSpPr>
+          <p:nvPr/>
+        </p:nvSpPr>
+        <p:spPr>
+          <a:xfrm xmlns:a="http://schemas.openxmlformats.org/drawingml/2006/main">
+            <a:off x="9653778" y="2238375"/>
+            <a:ext cx="2130552" cy="285750"/>
+          </a:xfrm>
+          <a:prstGeom xmlns:a="http://schemas.openxmlformats.org/drawingml/2006/main" prst="rect">
+            <a:avLst/>
+          </a:prstGeom>
+        </p:spPr>
+        <p:txBody>
+          <a:bodyPr xmlns:a="http://schemas.openxmlformats.org/drawingml/2006/main" wrap="square" lIns="0" tIns="0" rIns="0" bIns="0" anchor="t">
+            <a:normAutofit fontScale="100000"/>
+          </a:bodyPr>
+          <a:lstStyle xmlns:a="http://schemas.openxmlformats.org/drawingml/2006/main"/>
+          <a:p xmlns:a="http://schemas.openxmlformats.org/drawingml/2006/main">
+            <a:pPr algn="l">
+              <a:defRPr sz="1350" b="1">
+                <a:solidFill>
+                  <a:srgbClr val="FF7A59"/>
+                </a:solidFill>
+                <a:latin typeface="Aptos"/>
+                <a:ea typeface="Aptos"/>
+                <a:cs typeface="Aptos"/>
+              </a:defRPr>
+            </a:pPr>
+            <a:r>
+              <a:t>2026–now</a:t>
+            </a:r>
+          </a:p>
+        </p:txBody>
+      </p:sp>
+      <p:sp>
+        <p:nvSpPr>
+          <p:cNvPr id="41" name="timeline-org-4">
+            <a:extLst xmlns:a="http://schemas.openxmlformats.org/drawingml/2006/main">
+              <a:ext uri="{FF2B5EF4-FFF2-40B4-BE49-F238E27FC236}">
+                <a16:creationId xmlns:a16="http://schemas.microsoft.com/office/drawing/2014/main" id="{BE44C1F6-AF52-4E09-A859-FAD7EB352F45}"/>
+              </a:ext>
+            </a:extLst>
+          </p:cNvPr>
+          <p:cNvSpPr>
+            <a:spLocks xmlns:a="http://schemas.openxmlformats.org/drawingml/2006/main" noGrp="1"/>
+          </p:cNvSpPr>
+          <p:nvPr/>
+        </p:nvSpPr>
+        <p:spPr>
+          <a:xfrm xmlns:a="http://schemas.openxmlformats.org/drawingml/2006/main">
+            <a:off x="9653778" y="3343275"/>
+            <a:ext cx="2130552" cy="552450"/>
+          </a:xfrm>
+          <a:prstGeom xmlns:a="http://schemas.openxmlformats.org/drawingml/2006/main" prst="rect">
+            <a:avLst/>
+          </a:prstGeom>
+        </p:spPr>
+        <p:txBody>
+          <a:bodyPr xmlns:a="http://schemas.openxmlformats.org/drawingml/2006/main" wrap="square" lIns="0" tIns="0" rIns="0" bIns="0" anchor="t">
+            <a:normAutofit fontScale="100000"/>
+          </a:bodyPr>
+          <a:lstStyle xmlns:a="http://schemas.openxmlformats.org/drawingml/2006/main"/>
+          <a:p xmlns:a="http://schemas.openxmlformats.org/drawingml/2006/main">
+            <a:pPr algn="l">
+              <a:defRPr sz="1800" b="1">
+                <a:solidFill>
+                  <a:srgbClr val="FFF7ED"/>
+                </a:solidFill>
+                <a:latin typeface="Aptos"/>
+                <a:ea typeface="Aptos"/>
+                <a:cs typeface="Aptos"/>
+              </a:defRPr>
+            </a:pPr>
+            <a:r>
+              <a:t>Cerebrum</a:t>
+            </a:r>
+          </a:p>
+        </p:txBody>
+      </p:sp>
+      <p:sp>
+        <p:nvSpPr>
+          <p:cNvPr id="42" name="timeline-role-4">
+            <a:extLst xmlns:a="http://schemas.openxmlformats.org/drawingml/2006/main">
+              <a:ext uri="{FF2B5EF4-FFF2-40B4-BE49-F238E27FC236}">
+                <a16:creationId xmlns:a16="http://schemas.microsoft.com/office/drawing/2014/main" id="{2D8770E6-6A18-45E9-AF57-2D1723B5AD7D}"/>
+              </a:ext>
+            </a:extLst>
+          </p:cNvPr>
+          <p:cNvSpPr>
+            <a:spLocks xmlns:a="http://schemas.openxmlformats.org/drawingml/2006/main" noGrp="1"/>
+          </p:cNvSpPr>
+          <p:nvPr/>
+        </p:nvSpPr>
+        <p:spPr>
+          <a:xfrm xmlns:a="http://schemas.openxmlformats.org/drawingml/2006/main">
+            <a:off x="9653778" y="3971925"/>
+            <a:ext cx="2130552" cy="466725"/>
+          </a:xfrm>
+          <a:prstGeom xmlns:a="http://schemas.openxmlformats.org/drawingml/2006/main" prst="rect">
+            <a:avLst/>
+          </a:prstGeom>
+        </p:spPr>
+        <p:txBody>
+          <a:bodyPr xmlns:a="http://schemas.openxmlformats.org/drawingml/2006/main" wrap="square" lIns="0" tIns="0" rIns="0" bIns="0" anchor="t">
+            <a:normAutofit fontScale="100000"/>
+          </a:bodyPr>
+          <a:lstStyle xmlns:a="http://schemas.openxmlformats.org/drawingml/2006/main"/>
+          <a:p xmlns:a="http://schemas.openxmlformats.org/drawingml/2006/main">
+            <a:pPr algn="l">
+              <a:defRPr sz="1200" b="0">
+                <a:solidFill>
+                  <a:srgbClr val="B9A59B"/>
+                </a:solidFill>
+                <a:latin typeface="Aptos"/>
+                <a:ea typeface="Aptos"/>
+                <a:cs typeface="Aptos"/>
+              </a:defRPr>
+            </a:pPr>
+            <a:r>
+              <a:t>Data &amp; AI Engineer</a:t>
+            </a:r>
+          </a:p>
+        </p:txBody>
+      </p:sp>
+      <p:sp>
+        <p:nvSpPr>
+          <p:cNvPr id="43" name="timeline-result-4">
+            <a:extLst xmlns:a="http://schemas.openxmlformats.org/drawingml/2006/main">
+              <a:ext uri="{FF2B5EF4-FFF2-40B4-BE49-F238E27FC236}">
+                <a16:creationId xmlns:a16="http://schemas.microsoft.com/office/drawing/2014/main" id="{1A879A9C-A00B-4B6B-97A4-D98BC34FC373}"/>
+              </a:ext>
+            </a:extLst>
+          </p:cNvPr>
+          <p:cNvSpPr>
+            <a:spLocks xmlns:a="http://schemas.openxmlformats.org/drawingml/2006/main" noGrp="1"/>
+          </p:cNvSpPr>
+          <p:nvPr/>
+        </p:nvSpPr>
+        <p:spPr>
+          <a:xfrm xmlns:a="http://schemas.openxmlformats.org/drawingml/2006/main">
+            <a:off x="9653778" y="4695825"/>
+            <a:ext cx="2130552" cy="822960"/>
+          </a:xfrm>
+          <a:prstGeom xmlns:a="http://schemas.openxmlformats.org/drawingml/2006/main" prst="rect">
+            <a:avLst/>
+          </a:prstGeom>
+        </p:spPr>
+        <p:txBody>
+          <a:bodyPr xmlns:a="http://schemas.openxmlformats.org/drawingml/2006/main" wrap="square" lIns="0" tIns="0" rIns="0" bIns="0" anchor="t">
+            <a:normAutofit fontScale="100000"/>
+          </a:bodyPr>
+          <a:lstStyle xmlns:a="http://schemas.openxmlformats.org/drawingml/2006/main"/>
+          <a:p xmlns:a="http://schemas.openxmlformats.org/drawingml/2006/main">
+            <a:pPr algn="l">
+              <a:defRPr sz="1200" b="1">
+                <a:solidFill>
+                  <a:srgbClr val="FFF7ED"/>
+                </a:solidFill>
+                <a:latin typeface="Aptos"/>
+                <a:ea typeface="Aptos"/>
+                <a:cs typeface="Aptos"/>
+              </a:defRPr>
+            </a:pPr>
+            <a:r>
+              <a:t>33.5K+ questions auto-QC'd · LLM content pipelines</a:t>
             </a:r>
           </a:p>
         </p:txBody>

</xml_diff>